<commit_message>
Update H1 Intro - Dynamische Websites.pptx
</commit_message>
<xml_diff>
--- a/H1 - Intro/Presentatie/H1 Intro - Dynamische Websites.pptx
+++ b/H1 - Intro/Presentatie/H1 Intro - Dynamische Websites.pptx
@@ -146,7 +146,7 @@
 <file path=ppt/revisionInfo.xml><?xml version="1.0" encoding="utf-8"?>
 <p1510:revInfo xmlns:a="http://schemas.openxmlformats.org/drawingml/2006/main" xmlns:r="http://schemas.openxmlformats.org/officeDocument/2006/relationships" xmlns:p1510="http://schemas.microsoft.com/office/powerpoint/2015/10/main">
   <p1510:revLst>
-    <p1510:client id="{5FE9E73C-79B0-7DA8-F607-7F42D35FEE39}" v="2320" dt="2025-10-23T16:34:25.365"/>
+    <p1510:client id="{96D01377-C3D2-3B45-5E36-237F984D1208}" v="34" dt="2026-04-15T22:57:53.844"/>
   </p1510:revLst>
 </p1510:revInfo>
 </file>
@@ -5753,7 +5753,7 @@
           <a:p>
             <a:fld id="{6706355E-35B0-47A6-8E00-D68DE081856C}" type="datetimeFigureOut">
               <a:rPr lang="nl-BE" smtClean="0"/>
-              <a:t>23/10/2025</a:t>
+              <a:t>15/04/2026</a:t>
             </a:fld>
             <a:endParaRPr lang="nl-BE"/>
           </a:p>
@@ -6213,7 +6213,7 @@
           <a:p>
             <a:fld id="{39DBD449-D42A-4711-8837-53EC15580D9C}" type="slidenum">
               <a:rPr lang="nl-BE" smtClean="0"/>
-              <a:t>9</a:t>
+              <a:t>10</a:t>
             </a:fld>
             <a:endParaRPr lang="nl-BE"/>
           </a:p>
@@ -6295,9 +6295,10 @@
           <a:lstStyle/>
           <a:p>
             <a:r>
-              <a:rPr lang="nl-BE" dirty="0"/>
-              <a:t>Dit zijn enkele belangrijke methodes die gebruikt worden bij het verwerken van HTTP verzoeken. Binnenkort gebruiken. </a:t>
-            </a:r>
+              <a:rPr lang="nl-BE"/>
+              <a:t>Dit zijn enkele belangrijke methodes die gebruikt worden bij het verwerken van HTTP verzoeken. Binnenkort gebruiken.  Dit is typisch beeld dat je krijgt van tools zoals Swagger en OpenAPI</a:t>
+            </a:r>
+            <a:endParaRPr lang="nl-BE" dirty="0"/>
           </a:p>
           <a:p>
             <a:endParaRPr lang="nl-BE" dirty="0"/>
@@ -6308,11 +6309,11 @@
               <a:t>De </a:t>
             </a:r>
             <a:r>
-              <a:rPr lang="nl-BE" dirty="0" err="1"/>
+              <a:rPr lang="nl-BE" err="1"/>
               <a:t>Request</a:t>
             </a:r>
             <a:r>
-              <a:rPr lang="nl-BE" dirty="0"/>
+              <a:rPr lang="nl-BE"/>
               <a:t> Method staat links: “GET, PUT, DELETE en POST”. Een voorbeeld van de route staat rechts. We zullen regelmatig routes overslaan omdat het ook zonder kan.</a:t>
             </a:r>
           </a:p>
@@ -6341,7 +6342,7 @@
           <a:p>
             <a:fld id="{39DBD449-D42A-4711-8837-53EC15580D9C}" type="slidenum">
               <a:rPr lang="nl-BE" smtClean="0"/>
-              <a:t>10</a:t>
+              <a:t>11</a:t>
             </a:fld>
             <a:endParaRPr lang="nl-BE"/>
           </a:p>
@@ -6503,7 +6504,7 @@
           <a:p>
             <a:fld id="{39DBD449-D42A-4711-8837-53EC15580D9C}" type="slidenum">
               <a:rPr lang="nl-BE" smtClean="0"/>
-              <a:t>8</a:t>
+              <a:t>12</a:t>
             </a:fld>
             <a:endParaRPr lang="nl-BE"/>
           </a:p>
@@ -6611,7 +6612,7 @@
           <a:p>
             <a:fld id="{39DBD449-D42A-4711-8837-53EC15580D9C}" type="slidenum">
               <a:rPr lang="nl-BE" smtClean="0"/>
-              <a:t>11</a:t>
+              <a:t>13</a:t>
             </a:fld>
             <a:endParaRPr lang="nl-BE"/>
           </a:p>
@@ -6716,9 +6717,19 @@
               <a:buChar char="-"/>
             </a:pPr>
             <a:r>
-              <a:rPr lang="nl-BE" dirty="0"/>
+              <a:rPr lang="nl-BE"/>
               <a:t>PHP integreren tussen HTML</a:t>
             </a:r>
+            <a:br>
+              <a:rPr lang="nl-BE" dirty="0">
+                <a:cs typeface="+mn-lt"/>
+              </a:rPr>
+            </a:br>
+            <a:r>
+              <a:rPr lang="nl-BE"/>
+              <a:t>Let erop dat de bestandsnaam telkens moet eindigen op .PHP (ipv .HTML) vanaf het moment dat je iets van PHP integreert.</a:t>
+            </a:r>
+            <a:endParaRPr lang="nl-BE" dirty="0"/>
           </a:p>
         </p:txBody>
       </p:sp>
@@ -6745,7 +6756,7 @@
           <a:p>
             <a:fld id="{39DBD449-D42A-4711-8837-53EC15580D9C}" type="slidenum">
               <a:rPr lang="nl-BE" smtClean="0"/>
-              <a:t>12</a:t>
+              <a:t>14</a:t>
             </a:fld>
             <a:endParaRPr lang="nl-BE"/>
           </a:p>
@@ -6889,7 +6900,7 @@
           <a:p>
             <a:fld id="{39DBD449-D42A-4711-8837-53EC15580D9C}" type="slidenum">
               <a:rPr lang="nl-BE" smtClean="0"/>
-              <a:t>13</a:t>
+              <a:t>15</a:t>
             </a:fld>
             <a:endParaRPr lang="nl-BE"/>
           </a:p>
@@ -7000,7 +7011,7 @@
           <a:p>
             <a:fld id="{39DBD449-D42A-4711-8837-53EC15580D9C}" type="slidenum">
               <a:rPr lang="nl-BE" smtClean="0"/>
-              <a:t>14</a:t>
+              <a:t>16</a:t>
             </a:fld>
             <a:endParaRPr lang="nl-BE"/>
           </a:p>
@@ -7120,7 +7131,7 @@
           <a:p>
             <a:fld id="{39DBD449-D42A-4711-8837-53EC15580D9C}" type="slidenum">
               <a:rPr lang="nl-BE" smtClean="0"/>
-              <a:t>15</a:t>
+              <a:t>17</a:t>
             </a:fld>
             <a:endParaRPr lang="nl-BE"/>
           </a:p>
@@ -7249,7 +7260,7 @@
           <a:p>
             <a:fld id="{39DBD449-D42A-4711-8837-53EC15580D9C}" type="slidenum">
               <a:rPr lang="nl-BE" smtClean="0"/>
-              <a:t>16</a:t>
+              <a:t>18</a:t>
             </a:fld>
             <a:endParaRPr lang="nl-BE"/>
           </a:p>
@@ -7360,7 +7371,7 @@
           <a:p>
             <a:fld id="{39DBD449-D42A-4711-8837-53EC15580D9C}" type="slidenum">
               <a:rPr lang="nl-BE" smtClean="0"/>
-              <a:t>17</a:t>
+              <a:t>19</a:t>
             </a:fld>
             <a:endParaRPr lang="nl-BE"/>
           </a:p>
@@ -8075,7 +8086,7 @@
           <a:p>
             <a:fld id="{39DBD449-D42A-4711-8837-53EC15580D9C}" type="slidenum">
               <a:rPr lang="nl-BE" smtClean="0"/>
-              <a:t>18</a:t>
+              <a:t>20</a:t>
             </a:fld>
             <a:endParaRPr lang="nl-BE"/>
           </a:p>
@@ -8187,7 +8198,7 @@
           <a:p>
             <a:fld id="{39DBD449-D42A-4711-8837-53EC15580D9C}" type="slidenum">
               <a:rPr lang="nl-BE" smtClean="0"/>
-              <a:t>19</a:t>
+              <a:t>21</a:t>
             </a:fld>
             <a:endParaRPr lang="nl-BE"/>
           </a:p>
@@ -8295,7 +8306,7 @@
           <a:p>
             <a:fld id="{39DBD449-D42A-4711-8837-53EC15580D9C}" type="slidenum">
               <a:rPr lang="nl-BE" smtClean="0"/>
-              <a:t>20</a:t>
+              <a:t>22</a:t>
             </a:fld>
             <a:endParaRPr lang="nl-BE"/>
           </a:p>
@@ -8431,7 +8442,7 @@
           <a:p>
             <a:fld id="{39DBD449-D42A-4711-8837-53EC15580D9C}" type="slidenum">
               <a:rPr lang="nl-BE" smtClean="0"/>
-              <a:t>22</a:t>
+              <a:t>23</a:t>
             </a:fld>
             <a:endParaRPr lang="nl-BE"/>
           </a:p>
@@ -8571,7 +8582,7 @@
           <a:p>
             <a:fld id="{39DBD449-D42A-4711-8837-53EC15580D9C}" type="slidenum">
               <a:rPr lang="nl-BE" smtClean="0"/>
-              <a:t>23</a:t>
+              <a:t>24</a:t>
             </a:fld>
             <a:endParaRPr lang="nl-BE"/>
           </a:p>
@@ -8711,7 +8722,7 @@
           <a:p>
             <a:fld id="{39DBD449-D42A-4711-8837-53EC15580D9C}" type="slidenum">
               <a:rPr lang="nl-BE" smtClean="0"/>
-              <a:t>24</a:t>
+              <a:t>25</a:t>
             </a:fld>
             <a:endParaRPr lang="nl-BE"/>
           </a:p>
@@ -8819,7 +8830,7 @@
           <a:p>
             <a:fld id="{39DBD449-D42A-4711-8837-53EC15580D9C}" type="slidenum">
               <a:rPr lang="nl-BE" smtClean="0"/>
-              <a:t>25</a:t>
+              <a:t>26</a:t>
             </a:fld>
             <a:endParaRPr lang="nl-BE"/>
           </a:p>
@@ -8955,7 +8966,7 @@
           <a:p>
             <a:fld id="{39DBD449-D42A-4711-8837-53EC15580D9C}" type="slidenum">
               <a:rPr lang="nl-BE" smtClean="0"/>
-              <a:t>21</a:t>
+              <a:t>27</a:t>
             </a:fld>
             <a:endParaRPr lang="nl-BE"/>
           </a:p>
@@ -9083,7 +9094,7 @@
           <a:p>
             <a:fld id="{39DBD449-D42A-4711-8837-53EC15580D9C}" type="slidenum">
               <a:rPr lang="nl-BE" smtClean="0"/>
-              <a:t>27</a:t>
+              <a:t>28</a:t>
             </a:fld>
             <a:endParaRPr lang="nl-BE"/>
           </a:p>
@@ -9191,7 +9202,7 @@
           <a:p>
             <a:fld id="{39DBD449-D42A-4711-8837-53EC15580D9C}" type="slidenum">
               <a:rPr lang="nl-BE" smtClean="0"/>
-              <a:t>28</a:t>
+              <a:t>29</a:t>
             </a:fld>
             <a:endParaRPr lang="nl-BE"/>
           </a:p>
@@ -9361,7 +9372,7 @@
           <a:p>
             <a:fld id="{39DBD449-D42A-4711-8837-53EC15580D9C}" type="slidenum">
               <a:rPr lang="nl-BE" smtClean="0"/>
-              <a:t>5</a:t>
+              <a:t>3</a:t>
             </a:fld>
             <a:endParaRPr lang="nl-BE"/>
           </a:p>
@@ -9581,7 +9592,7 @@
           <a:p>
             <a:fld id="{39DBD449-D42A-4711-8837-53EC15580D9C}" type="slidenum">
               <a:rPr lang="nl-BE" smtClean="0"/>
-              <a:t>3</a:t>
+              <a:t>5</a:t>
             </a:fld>
             <a:endParaRPr lang="nl-BE"/>
           </a:p>
@@ -9901,7 +9912,7 @@
           <a:p>
             <a:fld id="{39DBD449-D42A-4711-8837-53EC15580D9C}" type="slidenum">
               <a:rPr lang="nl-BE" smtClean="0"/>
-              <a:t>3</a:t>
+              <a:t>7</a:t>
             </a:fld>
             <a:endParaRPr lang="nl-BE"/>
           </a:p>
@@ -10050,7 +10061,7 @@
           <a:p>
             <a:fld id="{39DBD449-D42A-4711-8837-53EC15580D9C}" type="slidenum">
               <a:rPr lang="nl-BE" smtClean="0"/>
-              <a:t>4</a:t>
+              <a:t>8</a:t>
             </a:fld>
             <a:endParaRPr lang="nl-BE"/>
           </a:p>
@@ -10114,8 +10125,8 @@
           <a:lstStyle/>
           <a:p>
             <a:r>
-              <a:rPr lang="nl-BE" dirty="0"/>
-              <a:t>We gebruiken het OSI model om de lagen van de informatica op te splitsen in verantwoordelijkheden. PHP draait op Laag 7. PHP accepteert wel gegevens vanuit alle onderliggende lagen zoals de </a:t>
+              <a:rPr lang="nl-BE"/>
+              <a:t>We gebruiken het OSI model om de lagen van de informatica op te splitsen in verantwoordelijkheden. PHP draait op Laag 7: de applicatielaag. PHP accepteert gegevens vanuit alle onderliggende lagen zoals de </a:t>
             </a:r>
             <a:r>
               <a:rPr lang="nl-BE" dirty="0" err="1"/>
@@ -10145,7 +10156,7 @@
           <a:p>
             <a:fld id="{39DBD449-D42A-4711-8837-53EC15580D9C}" type="slidenum">
               <a:rPr lang="nl-BE" smtClean="0"/>
-              <a:t>7</a:t>
+              <a:t>9</a:t>
             </a:fld>
             <a:endParaRPr lang="nl-BE"/>
           </a:p>
@@ -10317,7 +10328,7 @@
           <a:p>
             <a:fld id="{C128FA71-3A18-48C0-980F-4B68F7F63042}" type="datetime1">
               <a:rPr lang="en-US" smtClean="0"/>
-              <a:t>10/23/2025</a:t>
+              <a:t>4/15/2026</a:t>
             </a:fld>
             <a:endParaRPr lang="en-US"/>
           </a:p>
@@ -10525,7 +10536,7 @@
           <a:p>
             <a:fld id="{7104EDB3-C0E8-45F8-9E1D-1B6C8D1880C0}" type="datetime1">
               <a:rPr lang="en-US" smtClean="0"/>
-              <a:t>10/23/2025</a:t>
+              <a:t>4/15/2026</a:t>
             </a:fld>
             <a:endParaRPr lang="en-US"/>
           </a:p>
@@ -10735,7 +10746,7 @@
           <a:p>
             <a:fld id="{9CF0EC4B-54ED-4041-B552-9BA760FA3DBA}" type="datetime1">
               <a:rPr lang="en-US" smtClean="0"/>
-              <a:t>10/23/2025</a:t>
+              <a:t>4/15/2026</a:t>
             </a:fld>
             <a:endParaRPr lang="en-US"/>
           </a:p>
@@ -10933,7 +10944,7 @@
           <a:p>
             <a:fld id="{51C1210E-201E-4473-82AC-2466F5386C38}" type="datetime1">
               <a:rPr lang="en-US" smtClean="0"/>
-              <a:t>10/23/2025</a:t>
+              <a:t>4/15/2026</a:t>
             </a:fld>
             <a:endParaRPr lang="en-US"/>
           </a:p>
@@ -11211,7 +11222,7 @@
           <a:p>
             <a:fld id="{B01EA198-6CAB-4B8F-B93F-1F9C8C4B6CE7}" type="datetime1">
               <a:rPr lang="en-US" smtClean="0"/>
-              <a:t>10/23/2025</a:t>
+              <a:t>4/15/2026</a:t>
             </a:fld>
             <a:endParaRPr lang="en-US"/>
           </a:p>
@@ -11483,7 +11494,7 @@
           <a:p>
             <a:fld id="{CA06041F-4525-44D5-AA4F-332294BF1F56}" type="datetime1">
               <a:rPr lang="en-US" smtClean="0"/>
-              <a:t>10/23/2025</a:t>
+              <a:t>4/15/2026</a:t>
             </a:fld>
             <a:endParaRPr lang="en-US"/>
           </a:p>
@@ -11907,7 +11918,7 @@
           <a:p>
             <a:fld id="{F9557091-BBDF-4EB9-BA6B-2BB67AC4FC0F}" type="datetime1">
               <a:rPr lang="en-US" smtClean="0"/>
-              <a:t>10/23/2025</a:t>
+              <a:t>4/15/2026</a:t>
             </a:fld>
             <a:endParaRPr lang="en-US"/>
           </a:p>
@@ -12048,7 +12059,7 @@
           <a:p>
             <a:fld id="{2D6B226B-77A6-410C-9796-083F278E0125}" type="datetime1">
               <a:rPr lang="en-US" smtClean="0"/>
-              <a:t>10/23/2025</a:t>
+              <a:t>4/15/2026</a:t>
             </a:fld>
             <a:endParaRPr lang="en-US"/>
           </a:p>
@@ -12161,7 +12172,7 @@
           <a:p>
             <a:fld id="{A23A578B-D289-4C40-8593-3D356C49DA58}" type="datetime1">
               <a:rPr lang="en-US" smtClean="0"/>
-              <a:t>10/23/2025</a:t>
+              <a:t>4/15/2026</a:t>
             </a:fld>
             <a:endParaRPr lang="en-US"/>
           </a:p>
@@ -12480,7 +12491,7 @@
           <a:p>
             <a:fld id="{713DFAE3-14DB-48A7-A80F-80DDB072CE3D}" type="datetime1">
               <a:rPr lang="en-US" smtClean="0"/>
-              <a:t>10/23/2025</a:t>
+              <a:t>4/15/2026</a:t>
             </a:fld>
             <a:endParaRPr lang="en-US"/>
           </a:p>
@@ -12774,7 +12785,7 @@
           <a:p>
             <a:fld id="{92C5EAEF-6478-4102-8F5D-A5FE9FC97ACB}" type="datetime1">
               <a:rPr lang="en-US" smtClean="0"/>
-              <a:t>10/23/2025</a:t>
+              <a:t>4/15/2026</a:t>
             </a:fld>
             <a:endParaRPr lang="en-US"/>
           </a:p>
@@ -13015,7 +13026,7 @@
           <a:p>
             <a:fld id="{67F45AC6-C491-4585-A584-9CE2AF7D5500}" type="datetime1">
               <a:rPr lang="en-US" smtClean="0"/>
-              <a:t>10/23/2025</a:t>
+              <a:t>4/15/2026</a:t>
             </a:fld>
             <a:endParaRPr lang="en-US"/>
           </a:p>
@@ -15786,13 +15797,10 @@
               <a:t>: start schrijven </a:t>
             </a:r>
             <a:r>
-              <a:rPr lang="nl-BE" sz="2200" b="1" err="1"/>
-              <a:t>php</a:t>
-            </a:r>
-            <a:r>
-              <a:rPr lang="nl-BE" sz="2200" b="1" dirty="0"/>
-              <a:t> code</a:t>
-            </a:r>
+              <a:rPr lang="nl-BE" sz="2200" b="1"/>
+              <a:t>php fragment code</a:t>
+            </a:r>
+            <a:endParaRPr lang="nl-BE" sz="2200" b="1" dirty="0"/>
           </a:p>
           <a:p>
             <a:endParaRPr lang="nl-BE" sz="2200" b="1" dirty="0"/>
@@ -15815,8 +15823,8 @@
               <a:t>php</a:t>
             </a:r>
             <a:r>
-              <a:rPr lang="nl-BE" sz="2200" b="1" dirty="0"/>
-              <a:t> code</a:t>
+              <a:rPr lang="nl-BE" sz="2200" b="1"/>
+              <a:t> fragment code</a:t>
             </a:r>
           </a:p>
         </p:txBody>
@@ -22870,10 +22878,10 @@
           <a:lstStyle/>
           <a:p>
             <a:r>
-              <a:rPr lang="en-US" sz="4000" dirty="0"/>
-              <a:t>Hoe dan met JavaScript?</a:t>
-            </a:r>
-            <a:endParaRPr lang="nl-NL" dirty="0"/>
+              <a:rPr lang="en-US" sz="4000"/>
+              <a:t>Anders dan JavaScript?</a:t>
+            </a:r>
+            <a:endParaRPr lang="nl-NL"/>
           </a:p>
         </p:txBody>
       </p:sp>
@@ -23431,6 +23439,48 @@
           </a:extLst>
         </p:spPr>
       </p:pic>
+      <p:sp>
+        <p:nvSpPr>
+          <p:cNvPr id="3" name="Tekstvak 2">
+            <a:extLst>
+              <a:ext uri="{FF2B5EF4-FFF2-40B4-BE49-F238E27FC236}">
+                <a16:creationId xmlns:a16="http://schemas.microsoft.com/office/drawing/2014/main" id="{E0D94CD8-8790-C998-B1B2-CE5EAA1B6FA1}"/>
+              </a:ext>
+            </a:extLst>
+          </p:cNvPr>
+          <p:cNvSpPr txBox="1"/>
+          <p:nvPr/>
+        </p:nvSpPr>
+        <p:spPr>
+          <a:xfrm>
+            <a:off x="8148203" y="3887931"/>
+            <a:ext cx="2606386" cy="923330"/>
+          </a:xfrm>
+          <a:prstGeom prst="rect">
+            <a:avLst/>
+          </a:prstGeom>
+          <a:noFill/>
+        </p:spPr>
+        <p:txBody>
+          <a:bodyPr rot="0" spcFirstLastPara="0" vertOverflow="overflow" horzOverflow="overflow" vert="horz" wrap="square" lIns="91440" tIns="45720" rIns="91440" bIns="45720" numCol="1" spcCol="0" rtlCol="0" fromWordArt="0" anchor="t" anchorCtr="0" forceAA="0" compatLnSpc="1">
+            <a:prstTxWarp prst="textNoShape">
+              <a:avLst/>
+            </a:prstTxWarp>
+            <a:spAutoFit/>
+          </a:bodyPr>
+          <a:lstStyle/>
+          <a:p>
+            <a:r>
+              <a:rPr lang="nl-NL" dirty="0"/>
+              <a:t>Link met </a:t>
+            </a:r>
+            <a:r>
+              <a:rPr lang="nl-NL"/>
+              <a:t>Datacommunicatie &amp; Netwerken!</a:t>
+            </a:r>
+          </a:p>
+        </p:txBody>
+      </p:sp>
     </p:spTree>
     <p:extLst>
       <p:ext uri="{BB962C8B-B14F-4D97-AF65-F5344CB8AC3E}">

</xml_diff>